<commit_message>
Replace presenter notes with timed 9-minute scripts split across three presenters
</commit_message>
<xml_diff>
--- a/KGCompass_Midpoint_Presentation.pptx
+++ b/KGCompass_Midpoint_Presentation.pptx
@@ -122,12 +122,12 @@
   <p:extLst>
     <p:ext uri="{521415D9-36F7-43E2-AB2F-B90AF26B5E84}">
       <p14:sectionLst xmlns:p14="http://schemas.microsoft.com/office/powerpoint/2010/main">
-        <p14:section name="Opening" id="{9031f274-976b-385c-6d51-db4305224bb3}">
+        <p14:section name="Opening" id="{1a7ea0b5-fa8b-fd7f-f7bd-9a82f45b6033}">
           <p14:sldIdLst>
             <p14:sldId id="256"/>
           </p14:sldIdLst>
         </p14:section>
-        <p14:section name="What We Built" id="{2c5e6374-b5da-78fd-279e-5dbe410a337d}">
+        <p14:section name="What We Built" id="{2c5c2c2f-3ac2-b3bb-b52e-bf6dec0dcc6b}">
           <p14:sldIdLst>
             <p14:sldId id="257"/>
             <p14:sldId id="258"/>
@@ -138,13 +138,13 @@
             <p14:sldId id="263"/>
           </p14:sldIdLst>
         </p14:section>
-        <p14:section name="RAG vs GraphRAG" id="{8b79e063-b64e-57da-df22-23f8e6d8d08a}">
+        <p14:section name="RAG vs GraphRAG" id="{27b2756c-9fcf-719a-dfa3-6139fcb9eb98}">
           <p14:sldIdLst>
             <p14:sldId id="264"/>
             <p14:sldId id="265"/>
           </p14:sldIdLst>
         </p14:section>
-        <p14:section name="Triplet Quality" id="{83a52a2b-6c42-6fe6-dcb4-b5bb7a9efbce}">
+        <p14:section name="Triplet Quality" id="{c5de1c1d-da1a-d3f4-a6bc-d266a8b8848d}">
           <p14:sldIdLst>
             <p14:sldId id="266"/>
             <p14:sldId id="267"/>
@@ -152,7 +152,7 @@
             <p14:sldId id="269"/>
           </p14:sldIdLst>
         </p14:section>
-        <p14:section name="Road Ahead" id="{f4990db0-ddd1-c618-8792-00caf4135c27}">
+        <p14:section name="Road Ahead" id="{6512dd7c-724f-950b-0758-ceaab6a56ef0}">
           <p14:sldIdLst>
             <p14:sldId id="270"/>
             <p14:sldId id="271"/>
@@ -1168,7 +1168,7 @@
           <a:p>
             <a:r>
               <a:rPr lang="en-US" dirty="0"/>
-              <a:t>Good afternoon everyone. This is our midpoint review. In one line: we built both a RAG system and a knowledge-graph GraphRAG system over 283 animal science papers in a single codebase, compared them head to head at two scales, then went one level deeper and evaluated the knowledge graph at the level of individual triplets. I will show what we built with code, what the comparisons found, why the giant graph underperformed, the five reasons triplets fail, and how we are correcting and re-verifying them so the KG quality rises.</a:t>
+              <a:t>[PERSON 1 | 0:20] Good afternoon. We're the TAU Group, advised by Professor Tao. KGCompass in one line: we built both a RAG system and a knowledge-graph system over 283 animal science papers, compared them head-to-head at two scales, and then evaluated the graph down to individual triplets. I'll show the system, Person 2 the evidence, Person 3 where we go next.</a:t>
             </a:r>
             <a:endParaRPr lang="en-US" dirty="0"/>
           </a:p>
@@ -1256,7 +1256,7 @@
           <a:p>
             <a:r>
               <a:rPr lang="en-US" dirty="0"/>
-              <a:t>Second comparison, and the interesting one: on the single giant graph over all 283 papers, RAG wins decisively - 431 to 221 with 87 ties, taking 33 of 38 groups, and GraphRAG paper recall collapses to 0.15 against RAG 0.29. And this time it is NOT the length artifact: RAG also wins at equal answer length and on expert-scored correctness. We measured the root cause: only 27 percent of GraphRAG seed entities come from the question own papers, so only about a quarter of its retrieved passages are on topic versus half for RAG. We can explain it mechanically, four compounding causes. One: retrieval expands only one hop, and in a thirty-thousand-entity graph one hop lands on mega-hubs like bovine milk with fifteen hundred edges rather than the specific path a multi-concept question needs. Two: the retrieval caps, forty entities, sixty relations, eight chunks, were sized for two-thousand-entity group graphs; at giant scale the budget fills with hub neighbours and the relevant chunk gets cut. Three: the step that rescues RAG at scale, cross-encoder reranking, simply does not exist on the graph path yet. Four: cross-corpus merging halved the entities but kept the edges, concentrating the graph and making hub expansion noisier. None of these is fundamental, all four are fixable retrieval engineering, which is exactly our plan.</a:t>
+              <a:t>[PERSON 2 | 0:50 - KEY SLIDE, know the four causes cold] Second comparison - the interesting one. On the single graph over all 283 papers, the result flips: RAG wins 431 to 221, takes 33 of 38 groups, and GraphRAG's paper recall collapses to 0.15. And this time it is NOT the length artifact - RAG wins at equal length and on expert-scored correctness. We know why, mechanically: retrieval expands only one hop, so it lands on mega-hubs like bovine milk with 1,576 edges; the retrieval caps were tuned for small graphs, so the relevant chunk falls outside the budget; the graph path has no reranker - the exact step that saves RAG; and merging concentrated the graph. The measured root cause at the bottom: only 27% of seed entities come from the question's own papers, so only 26% of retrieved passages are on-topic versus 51% for RAG. All four causes are fixable retrieval engineering.</a:t>
             </a:r>
             <a:endParaRPr lang="en-US" dirty="0"/>
           </a:p>
@@ -1344,7 +1344,7 @@
           <a:p>
             <a:r>
               <a:rPr lang="en-US" dirty="0"/>
-              <a:t>The answer-level comparison could not see graph errors: the judge called faithfulness a tie 83 percent of the time even though wrong facts sat in the graph. So, following Professor Tao's directive, we evaluated triplets directly, two layers. A deterministic code scan over every one of the 83,554 triples. And an LLM-judged sample: 950 triples, twenty-five per group, each verified against the full text of its actual source paper, every verdict with quoted evidence, and the method calibrated by two independent judges agreeing 94 percent on correct-versus-flawed. Result: 69 and a half percent fully correct, 26 percent imprecise, 4.4 percent outright wrong, and no group is clean.</a:t>
+              <a:t>[PERSON 2 | 0:35] Then we went a level deeper, because answer-level judging is blind to graph errors - faithfulness tied 83% of the time while wrong facts sat in the graph. Following Professor Tao's directive we verified triplets directly: a code scan of all 83,554, plus 950 triplets judged against the full text of their source papers, calibrated by two independent judges agreeing 94%. Result: 69.5% correct, 26% imprecise, 4.4% wrong - and no group is clean.</a:t>
             </a:r>
             <a:endParaRPr lang="en-US" dirty="0"/>
           </a:p>
@@ -1432,7 +1432,7 @@
           <a:p>
             <a:r>
               <a:rPr lang="en-US" dirty="0"/>
-              <a:t>Every failed triplet falls into one of five reasons. One, factual: the triple states something false, inverted directions, negative results flipped positive, abbreviations expanded into the wrong entity. Two, precision: the idea is right but the measured quantity or the condition was dropped, selenium increases liver instead of the selenium concentration in liver. Three, consistency: 495 pairs where the graph asserts both a claim and its opposite with no qualifiers. Four, form: OCR garbling, thirty of our thirty-four garbled entities come from one single corruption of the omega notation. Five, noise: triples that are true but worthless, is-measured-in facts and a seven-thousand-type relation vocabulary that dilute retrieval. Every example on this slide is a real triple from our graphs.</a:t>
+              <a:t>[PERSON 2 | 0:45] Every failed triplet has one of five reasons. One, factual - inverted directions: the graph says alfalfa silage increases milk yield; the paper shows the opposite. Two, precision - conditions dropped: 'iodine causes hypothyroidism' when the source says excess iodine. Three, consistency - 495 contradiction pairs like monensin both increasing and reducing feed efficiency. Four, form - OCR garbles; thirty of thirty-four come from one corruption of the omega notation. Five, noise - thousands of true-but-worthless 'is measured in' triples diluting retrieval. Every example here is a real triple from our graphs.</a:t>
             </a:r>
             <a:endParaRPr lang="en-US" dirty="0"/>
           </a:p>
@@ -1520,7 +1520,7 @@
           <a:p>
             <a:r>
               <a:rPr lang="en-US" dirty="0"/>
-              <a:t>Finding errors is only useful if it changes the graph, so we closed the loop. Detect: full-coverage detectors flag fifteen and a half thousand triples. Reason: every one of the 495 contradictions was adjudicated individually, and the headline is that fifty-six percent are not errors at all, they are dose or species conditional findings that need qualifiers, not deletion; twenty-one percent are extraction errors where one side gets deleted. The garbles were corrected, and the review also caught fourteen false positives from our own detector, which is why reasoning sits on top of rules. Correct, then re-verify against the source chunks which the schema already stores per triple. Each pass through this loop removes a named error class and is verified before it lands, so quality rises measurably.</a:t>
+              <a:t>[PERSON 2 | 0:35] Finding errors only matters if it changes the graph, so we closed the loop: detect, reason, correct, re-verify. The headline from adjudicating all 495 contradictions: 56% aren't errors at all - they're dose- or species-conditional findings that need qualifiers, not deletion. That's our research direction. 21% are extraction errors - deleted. Corrections are re-verified against source chunks before they land.</a:t>
             </a:r>
             <a:endParaRPr lang="en-US" dirty="0"/>
           </a:p>
@@ -1608,7 +1608,7 @@
           <a:p>
             <a:r>
               <a:rPr lang="en-US" dirty="0"/>
-              <a:t>The same loop as a workflow diagram, because this is what runs from now on: graphs in, deterministic detectors over every triple, a judged sample against the papers, case-by-case adjudication of contradictions, corrections, and re-verification against the source chunks - with the dashed arrow closing the loop so every release re-enters evaluation, and the CI gate guaranteeing no new mechanically-detectable defect ever lands.</a:t>
+              <a:t>[PERSON 2 | 0:15] The same loop as the standing workflow - every release re-enters evaluation, and a CI gate blocks any new detectable defect. HANDOFF: 'Person 3 - the plan.' (Designated skip slide if running over.)</a:t>
             </a:r>
             <a:endParaRPr lang="en-US" dirty="0"/>
           </a:p>
@@ -1696,7 +1696,7 @@
           <a:p>
             <a:r>
               <a:rPr lang="en-US" dirty="0"/>
-              <a:t>The second half of the semester has one sentence as its plan: find the best evaluation methods, and improve the knowledge graph until it passes them. Left side, evaluation: a CI gate so no mechanically detectable error ever enters a build, a judge stage checking every triple against its own source chunk, with HPRC allocation already in hand for the domain fine-tune, the gold set grown from our 950 verified triples, and the answer benchmark kept but length-controlled with an independent judge. Right side, improvement: fix exactly the four giant-graph causes, reranking on the graph path, multi-hop retrieval, adaptive caps; add qualifier fields, which is also our publishable contribution; normalize text before extraction. And then the rematch: re-run RAG versus GraphRAG at both scales with the cleaned graph.</a:t>
+              <a:t>[PERSON 3 | 1:00] The second half of the semester has a one-sentence plan: find the best evaluation methods, and improve the knowledge graph until it passes them. Evaluation side: the CI gate, a judge checking every triple against its own source chunk - HPRC allocation is already in hand for the domain fine-tune - the gold set grown from the 950 verified triplets, and the answer benchmark kept but length-controlled with an independent judge. Improvement side: fix exactly the four giant-graph causes - reranking on the graph path, multi-hop retrieval, adaptive caps; add dose-and-species qualifiers, which is also our publishable contribution; normalize text before extraction. And our success test is explicit: on the whole corpus, GraphRAG ties or beats RAG with length-matched answers, an independent judge, and an expert spot-check.</a:t>
             </a:r>
             <a:endParaRPr lang="en-US" dirty="0"/>
           </a:p>
@@ -1784,7 +1784,7 @@
           <a:p>
             <a:r>
               <a:rPr lang="en-US" dirty="0"/>
-              <a:t>To close. We built both systems end to end and evaluated them at every level, answers and triplets. We learned that GraphRAG wins when graphs are small, that at full scale the retrieval design gives the win back to RAG for four fixable reasons, and that about thirty percent of triplets are flawed for five nameable reasons, most of which are correctable and many of which are actually conditional science that needs a richer representation. That representation, qualified triples, is our research direction, and the correction and re-verification loop is already raising graph quality. By the final review we intend to show the rematch: the cleaned, re-verified knowledge graph passing its evaluation and beating RAG at full scale. Happy to take questions.</a:t>
+              <a:t>[PERSON 3 | 0:40] Where we stand: both systems built end-to-end; evaluated at every level, answers and triplets. We learned GraphRAG wins when graphs are small, that at scale retrieval design hands the win back to RAG for four fixable reasons, and that a third of triplets are flawed for five nameable reasons - many of which are actually conditional science needing richer representation. The correction loop is already raising quality. By the final review, we intend to show the rematch: the verified graph beating RAG at full scale. Thank you - happy to take questions. (Total: ~8:45, leaving ~15s for transitions.)</a:t>
             </a:r>
             <a:endParaRPr lang="en-US" dirty="0"/>
           </a:p>
@@ -1872,7 +1872,7 @@
           <a:p>
             <a:r>
               <a:rPr lang="en-US" dirty="0"/>
-              <a:t>The corpus is 283 animal science and nutrition papers organized into 42 topic groups. One codebase holds both pipelines: the original AnimalRAG retrieval pipeline, and the new knowledge-graph pipeline that builds graphs and answers with GraphRAG. We extracted 83 and a half thousand triples, built one graph per group plus one giant graph over all papers, and judged over sixteen hundred answer pairs plus nine hundred fifty individual triplets. The goal driving all of it: a knowledge graph trustworthy enough that GraphRAG reliably beats RAG.</a:t>
+              <a:t>[PERSON 1 | 0:25] The numbers that frame everything: 283 papers in 42 topic groups. Two pipelines in one codebase. 83,554 triples extracted into 39 graphs plus one giant graph. Nearly 1,700 answers judged. The goal: a knowledge graph trustworthy enough that GraphRAG reliably beats plain RAG.</a:t>
             </a:r>
             <a:endParaRPr lang="en-US" dirty="0"/>
           </a:p>
@@ -1960,7 +1960,7 @@
           <a:p>
             <a:r>
               <a:rPr lang="en-US" dirty="0"/>
-              <a:t>Before the how, the why. One Health questions, how a climate stressor ends up as a human exposure risk, span veterinary, climate and public-health literatures that rarely cite each other. Keyword and vector search return passages that share words with the question, not the chain of findings that actually answers it. A knowledge graph is the structure that can return that traceable path, each hop cited to its paper. That is the promise everything else in this talk is testing.</a:t>
+              <a:t>[PERSON 1 | 0:30] Why a knowledge graph at all? One Health questions - how a climate stressor becomes a human exposure risk - span veterinary, climate, and public-health papers that rarely cite each other. Search returns passages that share words with the question, not the chain of findings that answers it. This path on the right - stressor, physiology, disease, exposure - is what KGCompass should trace, every hop cited.</a:t>
             </a:r>
             <a:endParaRPr lang="en-US" dirty="0"/>
           </a:p>
@@ -2048,7 +2048,7 @@
           <a:p>
             <a:r>
               <a:rPr lang="en-US" dirty="0"/>
-              <a:t>Both pipelines live in one repository and share everything that must be fair: the same chunking, the same embedding model, the same LLM, gemma4 12B, for extraction, answering and judging. The RAG path is retrieval engineering: query expansion, hybrid dense plus keyword search, a cross-encoder reranker, then an answer with citations and a self-check. The GraphRAG path first builds a knowledge graph per corpus, then answers by walking the graph: seed entities, one hop out, top relationships, the chunks behind them and community summaries. Note one asymmetry now, it matters later: RAG has a reranker, the graph path does not.</a:t>
+              <a:t>[PERSON 1 | 0:30] One codebase, two pipelines, deliberately fair: same papers, same chunks, same LLM. RAG is retrieval engineering - query expansion, hybrid dense-plus-keyword search, a cross-encoder reranker, cited answers. GraphRAG builds a knowledge graph first, then answers by walking it. One asymmetry to remember: RAG has a reranker; the graph path doesn't. One command runs both on the same questions.</a:t>
             </a:r>
             <a:endParaRPr lang="en-US" dirty="0"/>
           </a:p>
@@ -2136,7 +2136,7 @@
           <a:p>
             <a:r>
               <a:rPr lang="en-US" dirty="0"/>
-              <a:t>This is the whole system on one picture. The corpus is chunked once, and both pipelines consume the same chunks. The top branch is RAG: embed and index into ChromaDB plus BM25, hybrid retrieval fused by reciprocal rank, then the cross-encoder reranker. The bottom branch builds the knowledge graph: LLM extraction with fourteen entity types, merging and community detection, storage in FalkorDB, and GraphRAG answering walks that graph. Both answers meet at the same LLM judge, scored in both orders on six criteria. The fairness controls matter: same chunks, same embeddings, same model everywhere.</a:t>
+              <a:t>[PERSON 1 | 0:25] The whole system in one picture. The corpus is chunked once; both pipelines consume the same chunks. Top branch RAG, bottom branch the graph build into FalkorDB, and both answers meet at the same LLM judge, scored in both orders to cancel position bias.</a:t>
             </a:r>
             <a:endParaRPr lang="en-US" dirty="0"/>
           </a:p>
@@ -2224,7 +2224,7 @@
           <a:p>
             <a:r>
               <a:rPr lang="en-US" dirty="0"/>
-              <a:t>Before the graphs, here is what the RAG side actually stores: twenty thousand chunks in ChromaDB, each with its seven-hundred-sixty-eight-dimension embedding, pictured as the blue strips. A question becomes its own vector, finds nearest neighbours by cosine similarity, BM25 finds keyword matches in parallel, reciprocal-rank fusion merges the two lists, and the cross-encoder reranks before answering. Keep this picture in mind - the reranker on the right is the piece the graph path is missing.</a:t>
+              <a:t>[PERSON 1 | 0:20] Inside the RAG store: twenty thousand chunks in ChromaDB, each with its embedding. A question becomes a vector, cosine search plus BM25, fused, then reranked. Keep the reranker in mind - it matters later. (Gesture at the figure and move on - designated skip slide if running over.)</a:t>
             </a:r>
             <a:endParaRPr lang="en-US" dirty="0"/>
           </a:p>
@@ -2312,7 +2312,7 @@
           <a:p>
             <a:r>
               <a:rPr lang="en-US" dirty="0"/>
-              <a:t>This is the actual build pipeline from the CLI, not pseudocode: prepare corpus, run extraction with a per-chunk cache so no chunk is ever paid for twice, build and merge the graph, detect communities, write summaries, embed entities, store everything in FalkorDB and export readable tables. One command builds a group graph, one command builds the giant graph over all 283 papers. The numbers on the right: twenty thousand chunks, fifty-five thousand entities across the group graphs. Notice the giant graph: merging across the whole corpus collapses entities by forty-five percent while keeping nearly all edges. Hold that thought, it explains a result coming up.</a:t>
+              <a:t>[PERSON 1 | 0:25] This is the actual build pipeline, not pseudocode: extract - cached per chunk so nothing is paid twice - merge, detect communities, store, export. One command per group, one command for all 283 papers. Note the right side: merging the giant graph collapses entities by 45% while keeping nearly all edges. Hold that thought.</a:t>
             </a:r>
             <a:endParaRPr lang="en-US" dirty="0"/>
           </a:p>
@@ -2400,7 +2400,7 @@
           <a:p>
             <a:r>
               <a:rPr lang="en-US" dirty="0"/>
-              <a:t>And here are the graphs themselves, not a schematic: every node and edge on this slide is drawn from the exported triples. Left to right: the iodine and thyroid group with iodine as its hub, the meat quality group, the pig gut microbiota group - and there are thirty-eight of these, one per topic. On the right, the giant graph over all two hundred eighty-three papers: the sample neighbourhood shows how merging connects entities across topics - aflatoxin linking kidney, broilers and oxidative stress - and the faded dots stand for the other thirty thousand entities. Node colors are the extraction's own entity types.</a:t>
+              <a:t>[PERSON 1 | 0:30] And the graphs themselves - every node and edge here is drawn from our real exported triples. Iodine-and-thyroid, meat quality, gut microbiota - 38 of these. On the right, the giant graph: merging connects entities across topics, aflatoxin linking kidneys, broilers, oxidative stress - and the faded dots stand for thirty thousand more entities. HANDOFF: 'Person 2 - what the evaluations found.'</a:t>
             </a:r>
             <a:endParaRPr lang="en-US" dirty="0"/>
           </a:p>
@@ -2488,7 +2488,7 @@
           <a:p>
             <a:r>
               <a:rPr lang="en-US" dirty="0"/>
-              <a:t>First comparison: one graph per topic group, 739 questions, every pair judged twice with the order swapped to kill position bias. GraphRAG wins 455 to 186, takes 35 of 38 groups, and on the expert test set it finds more of the right papers, recall 0.53 versus 0.42, while correctness is tied at the ceiling for both. It is also faster because RAG spends extra LLM calls on query rewriting and self-checking. The honest caveat we flagged ourselves: the LLM judge prefers longer answers, and when answers are the same length the two systems tie. So the groupwise result says GraphRAG retrieves richer context, not yet that its answers are strictly better.</a:t>
+              <a:t>[PERSON 2 | 0:35] Two comparisons. First, groupwise: 739 questions, one graph per topic. GraphRAG wins 455 to 186, takes 35 of 38 groups, finds more of the right papers - recall 0.53 versus 0.42 - and is faster. One honest caveat we found ourselves: the LLM judge rewards longer answers, and at equal length the systems tie. So groupwise says GraphRAG retrieves richer context - not yet that it's strictly better.</a:t>
             </a:r>
             <a:endParaRPr lang="en-US" dirty="0"/>
           </a:p>

</xml_diff>